<commit_message>
Added DataTable & DataBase
</commit_message>
<xml_diff>
--- a/ItayZabrovskyWebSite/Imgs/ImgCreate.pptx
+++ b/ItayZabrovskyWebSite/Imgs/ImgCreate.pptx
@@ -259,7 +259,7 @@
           <a:p>
             <a:fld id="{D1215001-F84D-490B-A77B-87B3F008CB51}" type="datetimeFigureOut">
               <a:rPr lang="he-IL" smtClean="0"/>
-              <a:t>כ"ה/טבת/תשפ"ו</a:t>
+              <a:t>י"ב/אייר/תשפ"ו</a:t>
             </a:fld>
             <a:endParaRPr lang="he-IL"/>
           </a:p>
@@ -457,7 +457,7 @@
           <a:p>
             <a:fld id="{D1215001-F84D-490B-A77B-87B3F008CB51}" type="datetimeFigureOut">
               <a:rPr lang="he-IL" smtClean="0"/>
-              <a:t>כ"ה/טבת/תשפ"ו</a:t>
+              <a:t>י"ב/אייר/תשפ"ו</a:t>
             </a:fld>
             <a:endParaRPr lang="he-IL"/>
           </a:p>
@@ -665,7 +665,7 @@
           <a:p>
             <a:fld id="{D1215001-F84D-490B-A77B-87B3F008CB51}" type="datetimeFigureOut">
               <a:rPr lang="he-IL" smtClean="0"/>
-              <a:t>כ"ה/טבת/תשפ"ו</a:t>
+              <a:t>י"ב/אייר/תשפ"ו</a:t>
             </a:fld>
             <a:endParaRPr lang="he-IL"/>
           </a:p>
@@ -863,7 +863,7 @@
           <a:p>
             <a:fld id="{D1215001-F84D-490B-A77B-87B3F008CB51}" type="datetimeFigureOut">
               <a:rPr lang="he-IL" smtClean="0"/>
-              <a:t>כ"ה/טבת/תשפ"ו</a:t>
+              <a:t>י"ב/אייר/תשפ"ו</a:t>
             </a:fld>
             <a:endParaRPr lang="he-IL"/>
           </a:p>
@@ -1138,7 +1138,7 @@
           <a:p>
             <a:fld id="{D1215001-F84D-490B-A77B-87B3F008CB51}" type="datetimeFigureOut">
               <a:rPr lang="he-IL" smtClean="0"/>
-              <a:t>כ"ה/טבת/תשפ"ו</a:t>
+              <a:t>י"ב/אייר/תשפ"ו</a:t>
             </a:fld>
             <a:endParaRPr lang="he-IL"/>
           </a:p>
@@ -1403,7 +1403,7 @@
           <a:p>
             <a:fld id="{D1215001-F84D-490B-A77B-87B3F008CB51}" type="datetimeFigureOut">
               <a:rPr lang="he-IL" smtClean="0"/>
-              <a:t>כ"ה/טבת/תשפ"ו</a:t>
+              <a:t>י"ב/אייר/תשפ"ו</a:t>
             </a:fld>
             <a:endParaRPr lang="he-IL"/>
           </a:p>
@@ -1815,7 +1815,7 @@
           <a:p>
             <a:fld id="{D1215001-F84D-490B-A77B-87B3F008CB51}" type="datetimeFigureOut">
               <a:rPr lang="he-IL" smtClean="0"/>
-              <a:t>כ"ה/טבת/תשפ"ו</a:t>
+              <a:t>י"ב/אייר/תשפ"ו</a:t>
             </a:fld>
             <a:endParaRPr lang="he-IL"/>
           </a:p>
@@ -1956,7 +1956,7 @@
           <a:p>
             <a:fld id="{D1215001-F84D-490B-A77B-87B3F008CB51}" type="datetimeFigureOut">
               <a:rPr lang="he-IL" smtClean="0"/>
-              <a:t>כ"ה/טבת/תשפ"ו</a:t>
+              <a:t>י"ב/אייר/תשפ"ו</a:t>
             </a:fld>
             <a:endParaRPr lang="he-IL"/>
           </a:p>
@@ -2069,7 +2069,7 @@
           <a:p>
             <a:fld id="{D1215001-F84D-490B-A77B-87B3F008CB51}" type="datetimeFigureOut">
               <a:rPr lang="he-IL" smtClean="0"/>
-              <a:t>כ"ה/טבת/תשפ"ו</a:t>
+              <a:t>י"ב/אייר/תשפ"ו</a:t>
             </a:fld>
             <a:endParaRPr lang="he-IL"/>
           </a:p>
@@ -2380,7 +2380,7 @@
           <a:p>
             <a:fld id="{D1215001-F84D-490B-A77B-87B3F008CB51}" type="datetimeFigureOut">
               <a:rPr lang="he-IL" smtClean="0"/>
-              <a:t>כ"ה/טבת/תשפ"ו</a:t>
+              <a:t>י"ב/אייר/תשפ"ו</a:t>
             </a:fld>
             <a:endParaRPr lang="he-IL"/>
           </a:p>
@@ -2668,7 +2668,7 @@
           <a:p>
             <a:fld id="{D1215001-F84D-490B-A77B-87B3F008CB51}" type="datetimeFigureOut">
               <a:rPr lang="he-IL" smtClean="0"/>
-              <a:t>כ"ה/טבת/תשפ"ו</a:t>
+              <a:t>י"ב/אייר/תשפ"ו</a:t>
             </a:fld>
             <a:endParaRPr lang="he-IL"/>
           </a:p>
@@ -2909,7 +2909,7 @@
           <a:p>
             <a:fld id="{D1215001-F84D-490B-A77B-87B3F008CB51}" type="datetimeFigureOut">
               <a:rPr lang="he-IL" smtClean="0"/>
-              <a:t>כ"ה/טבת/תשפ"ו</a:t>
+              <a:t>י"ב/אייר/תשפ"ו</a:t>
             </a:fld>
             <a:endParaRPr lang="he-IL"/>
           </a:p>
@@ -3626,6 +3626,106 @@
           </a:p>
         </p:txBody>
       </p:sp>
+      <p:sp>
+        <p:nvSpPr>
+          <p:cNvPr id="2" name="מלבן: פינות אלכסוניות חתוכות 1">
+            <a:extLst>
+              <a:ext uri="{FF2B5EF4-FFF2-40B4-BE49-F238E27FC236}">
+                <a16:creationId xmlns:a16="http://schemas.microsoft.com/office/drawing/2014/main" id="{CC6E2451-D569-8913-0252-3F970B8B0452}"/>
+              </a:ext>
+            </a:extLst>
+          </p:cNvPr>
+          <p:cNvSpPr/>
+          <p:nvPr/>
+        </p:nvSpPr>
+        <p:spPr>
+          <a:xfrm>
+            <a:off x="923777" y="4368022"/>
+            <a:ext cx="1913207" cy="928467"/>
+          </a:xfrm>
+          <a:prstGeom prst="snip2DiagRect">
+            <a:avLst/>
+          </a:prstGeom>
+        </p:spPr>
+        <p:style>
+          <a:lnRef idx="2">
+            <a:schemeClr val="accent1">
+              <a:shade val="15000"/>
+            </a:schemeClr>
+          </a:lnRef>
+          <a:fillRef idx="1">
+            <a:schemeClr val="accent1"/>
+          </a:fillRef>
+          <a:effectRef idx="0">
+            <a:schemeClr val="accent1"/>
+          </a:effectRef>
+          <a:fontRef idx="minor">
+            <a:schemeClr val="lt1"/>
+          </a:fontRef>
+        </p:style>
+        <p:txBody>
+          <a:bodyPr rtlCol="1" anchor="ctr"/>
+          <a:lstStyle/>
+          <a:p>
+            <a:pPr algn="ctr"/>
+            <a:r>
+              <a:rPr lang="en-US" sz="3500" dirty="0"/>
+              <a:t>Admin</a:t>
+            </a:r>
+            <a:endParaRPr lang="he-IL" sz="3500" dirty="0"/>
+          </a:p>
+        </p:txBody>
+      </p:sp>
+      <p:sp>
+        <p:nvSpPr>
+          <p:cNvPr id="4" name="מלבן: פינות אלכסוניות חתוכות 3">
+            <a:extLst>
+              <a:ext uri="{FF2B5EF4-FFF2-40B4-BE49-F238E27FC236}">
+                <a16:creationId xmlns:a16="http://schemas.microsoft.com/office/drawing/2014/main" id="{2FCE7F77-6A26-F034-1BD1-15978BE3FE13}"/>
+              </a:ext>
+            </a:extLst>
+          </p:cNvPr>
+          <p:cNvSpPr/>
+          <p:nvPr/>
+        </p:nvSpPr>
+        <p:spPr>
+          <a:xfrm>
+            <a:off x="5139395" y="4368019"/>
+            <a:ext cx="1913207" cy="928467"/>
+          </a:xfrm>
+          <a:prstGeom prst="snip2DiagRect">
+            <a:avLst/>
+          </a:prstGeom>
+        </p:spPr>
+        <p:style>
+          <a:lnRef idx="2">
+            <a:schemeClr val="accent1">
+              <a:shade val="15000"/>
+            </a:schemeClr>
+          </a:lnRef>
+          <a:fillRef idx="1">
+            <a:schemeClr val="accent1"/>
+          </a:fillRef>
+          <a:effectRef idx="0">
+            <a:schemeClr val="accent1"/>
+          </a:effectRef>
+          <a:fontRef idx="minor">
+            <a:schemeClr val="lt1"/>
+          </a:fontRef>
+        </p:style>
+        <p:txBody>
+          <a:bodyPr rtlCol="1" anchor="ctr"/>
+          <a:lstStyle/>
+          <a:p>
+            <a:pPr algn="ctr"/>
+            <a:r>
+              <a:rPr lang="en-US" sz="3500" dirty="0"/>
+              <a:t>Sign Up</a:t>
+            </a:r>
+            <a:endParaRPr lang="he-IL" sz="3500" dirty="0"/>
+          </a:p>
+        </p:txBody>
+      </p:sp>
     </p:spTree>
     <p:extLst>
       <p:ext uri="{BB962C8B-B14F-4D97-AF65-F5344CB8AC3E}">

</xml_diff>

<commit_message>
Added all buttons, javascript, and log in, log out and registry logic.
</commit_message>
<xml_diff>
--- a/ItayZabrovskyWebSite/Imgs/ImgCreate.pptx
+++ b/ItayZabrovskyWebSite/Imgs/ImgCreate.pptx
@@ -259,7 +259,7 @@
           <a:p>
             <a:fld id="{D1215001-F84D-490B-A77B-87B3F008CB51}" type="datetimeFigureOut">
               <a:rPr lang="he-IL" smtClean="0"/>
-              <a:t>י"ב/אייר/תשפ"ו</a:t>
+              <a:t>ט"ו/סיון/תשפ"ו</a:t>
             </a:fld>
             <a:endParaRPr lang="he-IL"/>
           </a:p>
@@ -457,7 +457,7 @@
           <a:p>
             <a:fld id="{D1215001-F84D-490B-A77B-87B3F008CB51}" type="datetimeFigureOut">
               <a:rPr lang="he-IL" smtClean="0"/>
-              <a:t>י"ב/אייר/תשפ"ו</a:t>
+              <a:t>ט"ו/סיון/תשפ"ו</a:t>
             </a:fld>
             <a:endParaRPr lang="he-IL"/>
           </a:p>
@@ -665,7 +665,7 @@
           <a:p>
             <a:fld id="{D1215001-F84D-490B-A77B-87B3F008CB51}" type="datetimeFigureOut">
               <a:rPr lang="he-IL" smtClean="0"/>
-              <a:t>י"ב/אייר/תשפ"ו</a:t>
+              <a:t>ט"ו/סיון/תשפ"ו</a:t>
             </a:fld>
             <a:endParaRPr lang="he-IL"/>
           </a:p>
@@ -863,7 +863,7 @@
           <a:p>
             <a:fld id="{D1215001-F84D-490B-A77B-87B3F008CB51}" type="datetimeFigureOut">
               <a:rPr lang="he-IL" smtClean="0"/>
-              <a:t>י"ב/אייר/תשפ"ו</a:t>
+              <a:t>ט"ו/סיון/תשפ"ו</a:t>
             </a:fld>
             <a:endParaRPr lang="he-IL"/>
           </a:p>
@@ -1138,7 +1138,7 @@
           <a:p>
             <a:fld id="{D1215001-F84D-490B-A77B-87B3F008CB51}" type="datetimeFigureOut">
               <a:rPr lang="he-IL" smtClean="0"/>
-              <a:t>י"ב/אייר/תשפ"ו</a:t>
+              <a:t>ט"ו/סיון/תשפ"ו</a:t>
             </a:fld>
             <a:endParaRPr lang="he-IL"/>
           </a:p>
@@ -1403,7 +1403,7 @@
           <a:p>
             <a:fld id="{D1215001-F84D-490B-A77B-87B3F008CB51}" type="datetimeFigureOut">
               <a:rPr lang="he-IL" smtClean="0"/>
-              <a:t>י"ב/אייר/תשפ"ו</a:t>
+              <a:t>ט"ו/סיון/תשפ"ו</a:t>
             </a:fld>
             <a:endParaRPr lang="he-IL"/>
           </a:p>
@@ -1815,7 +1815,7 @@
           <a:p>
             <a:fld id="{D1215001-F84D-490B-A77B-87B3F008CB51}" type="datetimeFigureOut">
               <a:rPr lang="he-IL" smtClean="0"/>
-              <a:t>י"ב/אייר/תשפ"ו</a:t>
+              <a:t>ט"ו/סיון/תשפ"ו</a:t>
             </a:fld>
             <a:endParaRPr lang="he-IL"/>
           </a:p>
@@ -1956,7 +1956,7 @@
           <a:p>
             <a:fld id="{D1215001-F84D-490B-A77B-87B3F008CB51}" type="datetimeFigureOut">
               <a:rPr lang="he-IL" smtClean="0"/>
-              <a:t>י"ב/אייר/תשפ"ו</a:t>
+              <a:t>ט"ו/סיון/תשפ"ו</a:t>
             </a:fld>
             <a:endParaRPr lang="he-IL"/>
           </a:p>
@@ -2069,7 +2069,7 @@
           <a:p>
             <a:fld id="{D1215001-F84D-490B-A77B-87B3F008CB51}" type="datetimeFigureOut">
               <a:rPr lang="he-IL" smtClean="0"/>
-              <a:t>י"ב/אייר/תשפ"ו</a:t>
+              <a:t>ט"ו/סיון/תשפ"ו</a:t>
             </a:fld>
             <a:endParaRPr lang="he-IL"/>
           </a:p>
@@ -2380,7 +2380,7 @@
           <a:p>
             <a:fld id="{D1215001-F84D-490B-A77B-87B3F008CB51}" type="datetimeFigureOut">
               <a:rPr lang="he-IL" smtClean="0"/>
-              <a:t>י"ב/אייר/תשפ"ו</a:t>
+              <a:t>ט"ו/סיון/תשפ"ו</a:t>
             </a:fld>
             <a:endParaRPr lang="he-IL"/>
           </a:p>
@@ -2668,7 +2668,7 @@
           <a:p>
             <a:fld id="{D1215001-F84D-490B-A77B-87B3F008CB51}" type="datetimeFigureOut">
               <a:rPr lang="he-IL" smtClean="0"/>
-              <a:t>י"ב/אייר/תשפ"ו</a:t>
+              <a:t>ט"ו/סיון/תשפ"ו</a:t>
             </a:fld>
             <a:endParaRPr lang="he-IL"/>
           </a:p>
@@ -2909,7 +2909,7 @@
           <a:p>
             <a:fld id="{D1215001-F84D-490B-A77B-87B3F008CB51}" type="datetimeFigureOut">
               <a:rPr lang="he-IL" smtClean="0"/>
-              <a:t>י"ב/אייר/תשפ"ו</a:t>
+              <a:t>ט"ו/סיון/תשפ"ו</a:t>
             </a:fld>
             <a:endParaRPr lang="he-IL"/>
           </a:p>
@@ -3420,7 +3420,7 @@
             <a:pPr algn="ctr"/>
             <a:r>
               <a:rPr lang="en-US" sz="3500" dirty="0"/>
-              <a:t>Sign In</a:t>
+              <a:t>Log In</a:t>
             </a:r>
             <a:endParaRPr lang="he-IL" sz="3500" dirty="0"/>
           </a:p>

</xml_diff>